<commit_message>
v3.58.1: one poster, many looks
Harry's correction: dozens of posters meant dozens of looks for one
argument, not dozens of arguments, and the argument has a name -- agentAI,
the MTSU Great Robotics Lab's research-data platform for physical agents.

gen.py holds the content fixed (title, standfirst, one spine in Harry's
order) and varies only the style. styles.py defines six axes: five grids
built from the four authored figure widths, six palettes, four display
faces, four title treatments, four opening images and three densities, with
a dealt sampler so 36 looks cover the space. deck.py takes a Style; the
hand-built drafts still build with the default. Georgia bold needed its own
width estimate or the title wrapped onto the byline.

Co-Authored-By: Claude Fable 5.1 <noreply@anthropic.com>
Claude-Session: https://claude.ai/code/session_019GW1g5v3nTp9QATBzJYkkw
</commit_message>
<xml_diff>
--- a/docs/poster/draft_A_machine.pptx
+++ b/docs/poster/draft_A_machine.pptx
@@ -3097,13 +3097,13 @@
         <p:spPr>
           <a:xfrm>
             <a:off x="0" y="0"/>
-            <a:ext cx="43891200" cy="3931920"/>
+            <a:ext cx="43891200" cy="32918400"/>
           </a:xfrm>
           <a:prstGeom prst="rect">
             <a:avLst/>
           </a:prstGeom>
           <a:solidFill>
-            <a:srgbClr val="14314E"/>
+            <a:srgbClr val="FFFFFF"/>
           </a:solidFill>
           <a:ln>
             <a:noFill/>
@@ -3140,14 +3140,14 @@
         </p:nvSpPr>
         <p:spPr>
           <a:xfrm>
-            <a:off x="0" y="3931920"/>
-            <a:ext cx="43891200" cy="45720"/>
+            <a:off x="0" y="0"/>
+            <a:ext cx="43891200" cy="3931920"/>
           </a:xfrm>
           <a:prstGeom prst="rect">
             <a:avLst/>
           </a:prstGeom>
           <a:solidFill>
-            <a:srgbClr val="1C6FB5"/>
+            <a:srgbClr val="14314E"/>
           </a:solidFill>
           <a:ln>
             <a:noFill/>
@@ -3178,290 +3178,14 @@
       </p:sp>
       <p:sp>
         <p:nvSpPr>
-          <p:cNvPr id="4" name="TextBox 3"/>
-          <p:cNvSpPr txBox="1"/>
-          <p:nvPr/>
-        </p:nvSpPr>
-        <p:spPr>
-          <a:xfrm>
-            <a:off x="731520" y="384048"/>
-            <a:ext cx="42428160" cy="365760"/>
-          </a:xfrm>
-          <a:prstGeom prst="rect">
-            <a:avLst/>
-          </a:prstGeom>
-          <a:noFill/>
-        </p:spPr>
-        <p:txBody>
-          <a:bodyPr wrap="square" lIns="0" rIns="0" tIns="0" bIns="0">
-            <a:spAutoFit/>
-          </a:bodyPr>
-          <a:lstStyle/>
-          <a:p>
-            <a:pPr algn="l">
-              <a:lnSpc>
-                <a:spcPct val="95000"/>
-              </a:lnSpc>
-              <a:spcAft>
-                <a:spcPts val="0"/>
-              </a:spcAft>
-            </a:pPr>
-            <a:r>
-              <a:rPr sz="10800" b="1">
-                <a:solidFill>
-                  <a:srgbClr val="FFFFFF"/>
-                </a:solidFill>
-                <a:latin typeface="Arial"/>
-              </a:rPr>
-              <a:t>Two Field Robots and an Agent Platform for Laser Weeding</a:t>
-            </a:r>
-          </a:p>
-        </p:txBody>
-      </p:sp>
-      <p:sp>
-        <p:nvSpPr>
-          <p:cNvPr id="5" name="TextBox 4"/>
-          <p:cNvSpPr txBox="1"/>
-          <p:nvPr/>
-        </p:nvSpPr>
-        <p:spPr>
-          <a:xfrm>
-            <a:off x="731520" y="2121408"/>
-            <a:ext cx="42428160" cy="365760"/>
-          </a:xfrm>
-          <a:prstGeom prst="rect">
-            <a:avLst/>
-          </a:prstGeom>
-          <a:noFill/>
-        </p:spPr>
-        <p:txBody>
-          <a:bodyPr wrap="square" lIns="0" rIns="0" tIns="0" bIns="0">
-            <a:spAutoFit/>
-          </a:bodyPr>
-          <a:lstStyle/>
-          <a:p>
-            <a:pPr algn="l">
-              <a:lnSpc>
-                <a:spcPct val="100000"/>
-              </a:lnSpc>
-              <a:spcAft>
-                <a:spcPts val="0"/>
-              </a:spcAft>
-            </a:pPr>
-            <a:r>
-              <a:rPr sz="4000" b="1">
-                <a:solidFill>
-                  <a:srgbClr val="FFFFFF"/>
-                </a:solidFill>
-                <a:latin typeface="Arial"/>
-              </a:rPr>
-              <a:t>Harry He   ·   Hongbo Zhang</a:t>
-            </a:r>
-          </a:p>
-        </p:txBody>
-      </p:sp>
-      <p:sp>
-        <p:nvSpPr>
-          <p:cNvPr id="6" name="TextBox 5"/>
-          <p:cNvSpPr txBox="1"/>
-          <p:nvPr/>
-        </p:nvSpPr>
-        <p:spPr>
-          <a:xfrm>
-            <a:off x="731520" y="2761488"/>
-            <a:ext cx="42428160" cy="365760"/>
-          </a:xfrm>
-          <a:prstGeom prst="rect">
-            <a:avLst/>
-          </a:prstGeom>
-          <a:noFill/>
-        </p:spPr>
-        <p:txBody>
-          <a:bodyPr wrap="square" lIns="0" rIns="0" tIns="0" bIns="0">
-            <a:spAutoFit/>
-          </a:bodyPr>
-          <a:lstStyle/>
-          <a:p>
-            <a:pPr algn="l">
-              <a:lnSpc>
-                <a:spcPct val="100000"/>
-              </a:lnSpc>
-              <a:spcAft>
-                <a:spcPts val="0"/>
-              </a:spcAft>
-            </a:pPr>
-            <a:r>
-              <a:rPr sz="2400" b="0">
-                <a:solidFill>
-                  <a:srgbClr val="C2CEDA"/>
-                </a:solidFill>
-                <a:latin typeface="Arial"/>
-              </a:rPr>
-              <a:t>Department of Engineering Technology   ·   Middle Tennessee State University, Murfreesboro, TN, USA</a:t>
-            </a:r>
-          </a:p>
-        </p:txBody>
-      </p:sp>
-      <p:sp>
-        <p:nvSpPr>
-          <p:cNvPr id="7" name="TextBox 6"/>
-          <p:cNvSpPr txBox="1"/>
-          <p:nvPr/>
-        </p:nvSpPr>
-        <p:spPr>
-          <a:xfrm>
-            <a:off x="731520" y="4315968"/>
-            <a:ext cx="42428160" cy="365760"/>
-          </a:xfrm>
-          <a:prstGeom prst="rect">
-            <a:avLst/>
-          </a:prstGeom>
-          <a:noFill/>
-        </p:spPr>
-        <p:txBody>
-          <a:bodyPr wrap="square" lIns="0" rIns="0" tIns="0" bIns="0">
-            <a:spAutoFit/>
-          </a:bodyPr>
-          <a:lstStyle/>
-          <a:p>
-            <a:pPr algn="l">
-              <a:lnSpc>
-                <a:spcPct val="116000"/>
-              </a:lnSpc>
-              <a:spcAft>
-                <a:spcPts val="0"/>
-              </a:spcAft>
-            </a:pPr>
-            <a:r>
-              <a:rPr sz="3400" b="0">
-                <a:solidFill>
-                  <a:srgbClr val="1E293B"/>
-                </a:solidFill>
-                <a:latin typeface="Arial"/>
-              </a:rPr>
-              <a:t>Anyone can download a weed dataset this afternoon. Nobody can download the path from a robot in a Tennessee crop row to a trained checkpoint. We built that path, ran it unattended for fifteen rounds, and measured every stage of it, including the last one we have not closed.</a:t>
-            </a:r>
-          </a:p>
-        </p:txBody>
-      </p:sp>
-      <p:pic>
-        <p:nvPicPr>
-          <p:cNvPr id="8" name="Picture 7" descr="n_system.png"/>
-          <p:cNvPicPr>
-            <a:picLocks noChangeAspect="1"/>
-          </p:cNvPicPr>
-          <p:nvPr/>
-        </p:nvPicPr>
-        <p:blipFill>
-          <a:blip r:embed="rId2"/>
-          <a:stretch>
-            <a:fillRect/>
-          </a:stretch>
-        </p:blipFill>
-        <p:spPr>
-          <a:xfrm>
-            <a:off x="11704320" y="5623560"/>
-            <a:ext cx="20482560" cy="3383280"/>
-          </a:xfrm>
-          <a:prstGeom prst="rect">
-            <a:avLst/>
-          </a:prstGeom>
-        </p:spPr>
-      </p:pic>
-      <p:sp>
-        <p:nvSpPr>
-          <p:cNvPr id="9" name="TextBox 8"/>
-          <p:cNvSpPr txBox="1"/>
-          <p:nvPr/>
-        </p:nvSpPr>
-        <p:spPr>
-          <a:xfrm>
-            <a:off x="11704320" y="9116568"/>
-            <a:ext cx="20482560" cy="365760"/>
-          </a:xfrm>
-          <a:prstGeom prst="rect">
-            <a:avLst/>
-          </a:prstGeom>
-          <a:noFill/>
-        </p:spPr>
-        <p:txBody>
-          <a:bodyPr wrap="square" lIns="0" rIns="0" tIns="0" bIns="0">
-            <a:spAutoFit/>
-          </a:bodyPr>
-          <a:lstStyle/>
-          <a:p>
-            <a:pPr algn="l">
-              <a:lnSpc>
-                <a:spcPct val="118000"/>
-              </a:lnSpc>
-              <a:spcAft>
-                <a:spcPts val="0"/>
-              </a:spcAft>
-            </a:pPr>
-            <a:r>
-              <a:rPr sz="1600" b="0">
-                <a:solidFill>
-                  <a:srgbClr val="556575"/>
-                </a:solidFill>
-                <a:latin typeface="Arial"/>
-              </a:rPr>
-              <a:t>Figure 1.  The path as built, from a camera in a crop row to a checkpoint on the cluster. Every stage has run. Three qualifications ride on it. The collector and trainer are paused after a stop-loss on 2026-08-29. The supervisor is advisory and nothing it says is applied. And the last link is not closed: no robot frame has entered training, because none of them is labelled yet.</a:t>
-            </a:r>
-          </a:p>
-        </p:txBody>
-      </p:sp>
-      <p:sp>
-        <p:nvSpPr>
-          <p:cNvPr id="10" name="TextBox 9"/>
-          <p:cNvSpPr txBox="1"/>
-          <p:nvPr/>
-        </p:nvSpPr>
-        <p:spPr>
-          <a:xfrm>
-            <a:off x="731520" y="5623560"/>
-            <a:ext cx="10607040" cy="365760"/>
-          </a:xfrm>
-          <a:prstGeom prst="rect">
-            <a:avLst/>
-          </a:prstGeom>
-          <a:noFill/>
-        </p:spPr>
-        <p:txBody>
-          <a:bodyPr wrap="square" lIns="0" rIns="0" tIns="0" bIns="0">
-            <a:spAutoFit/>
-          </a:bodyPr>
-          <a:lstStyle/>
-          <a:p>
-            <a:pPr algn="l">
-              <a:lnSpc>
-                <a:spcPct val="95000"/>
-              </a:lnSpc>
-              <a:spcAft>
-                <a:spcPts val="0"/>
-              </a:spcAft>
-            </a:pPr>
-            <a:r>
-              <a:rPr sz="3400" b="1">
-                <a:solidFill>
-                  <a:srgbClr val="14314E"/>
-                </a:solidFill>
-                <a:latin typeface="Arial"/>
-              </a:rPr>
-              <a:t>The two vehicles</a:t>
-            </a:r>
-          </a:p>
-        </p:txBody>
-      </p:sp>
-      <p:sp>
-        <p:nvSpPr>
-          <p:cNvPr id="11" name="Rectangle 10"/>
+          <p:cNvPr id="4" name="Rectangle 3"/>
           <p:cNvSpPr/>
           <p:nvPr/>
         </p:nvSpPr>
         <p:spPr>
           <a:xfrm>
-            <a:off x="731520" y="6190488"/>
-            <a:ext cx="10607040" cy="27432"/>
+            <a:off x="0" y="3931920"/>
+            <a:ext cx="43891200" cy="45720"/>
           </a:xfrm>
           <a:prstGeom prst="rect">
             <a:avLst/>
@@ -3496,24 +3220,192 @@
           </a:p>
         </p:txBody>
       </p:sp>
+      <p:sp>
+        <p:nvSpPr>
+          <p:cNvPr id="5" name="TextBox 4"/>
+          <p:cNvSpPr txBox="1"/>
+          <p:nvPr/>
+        </p:nvSpPr>
+        <p:spPr>
+          <a:xfrm>
+            <a:off x="731520" y="384048"/>
+            <a:ext cx="42428160" cy="365760"/>
+          </a:xfrm>
+          <a:prstGeom prst="rect">
+            <a:avLst/>
+          </a:prstGeom>
+          <a:noFill/>
+        </p:spPr>
+        <p:txBody>
+          <a:bodyPr wrap="square" lIns="0" rIns="0" tIns="0" bIns="0">
+            <a:spAutoFit/>
+          </a:bodyPr>
+          <a:lstStyle/>
+          <a:p>
+            <a:pPr algn="l">
+              <a:lnSpc>
+                <a:spcPct val="95000"/>
+              </a:lnSpc>
+              <a:spcAft>
+                <a:spcPts val="0"/>
+              </a:spcAft>
+            </a:pPr>
+            <a:r>
+              <a:rPr sz="10800" b="1">
+                <a:solidFill>
+                  <a:srgbClr val="FFFFFF"/>
+                </a:solidFill>
+                <a:latin typeface="Arial"/>
+              </a:rPr>
+              <a:t>Two Field Robots and an Agent Platform for Laser Weeding</a:t>
+            </a:r>
+          </a:p>
+        </p:txBody>
+      </p:sp>
+      <p:sp>
+        <p:nvSpPr>
+          <p:cNvPr id="6" name="TextBox 5"/>
+          <p:cNvSpPr txBox="1"/>
+          <p:nvPr/>
+        </p:nvSpPr>
+        <p:spPr>
+          <a:xfrm>
+            <a:off x="731520" y="2121408"/>
+            <a:ext cx="42428160" cy="365760"/>
+          </a:xfrm>
+          <a:prstGeom prst="rect">
+            <a:avLst/>
+          </a:prstGeom>
+          <a:noFill/>
+        </p:spPr>
+        <p:txBody>
+          <a:bodyPr wrap="square" lIns="0" rIns="0" tIns="0" bIns="0">
+            <a:spAutoFit/>
+          </a:bodyPr>
+          <a:lstStyle/>
+          <a:p>
+            <a:pPr algn="l">
+              <a:lnSpc>
+                <a:spcPct val="100000"/>
+              </a:lnSpc>
+              <a:spcAft>
+                <a:spcPts val="0"/>
+              </a:spcAft>
+            </a:pPr>
+            <a:r>
+              <a:rPr sz="4000" b="1">
+                <a:solidFill>
+                  <a:srgbClr val="FFFFFF"/>
+                </a:solidFill>
+                <a:latin typeface="Arial"/>
+              </a:rPr>
+              <a:t>Harry He   ·   Hongbo Zhang</a:t>
+            </a:r>
+          </a:p>
+        </p:txBody>
+      </p:sp>
+      <p:sp>
+        <p:nvSpPr>
+          <p:cNvPr id="7" name="TextBox 6"/>
+          <p:cNvSpPr txBox="1"/>
+          <p:nvPr/>
+        </p:nvSpPr>
+        <p:spPr>
+          <a:xfrm>
+            <a:off x="731520" y="2761488"/>
+            <a:ext cx="42428160" cy="365760"/>
+          </a:xfrm>
+          <a:prstGeom prst="rect">
+            <a:avLst/>
+          </a:prstGeom>
+          <a:noFill/>
+        </p:spPr>
+        <p:txBody>
+          <a:bodyPr wrap="square" lIns="0" rIns="0" tIns="0" bIns="0">
+            <a:spAutoFit/>
+          </a:bodyPr>
+          <a:lstStyle/>
+          <a:p>
+            <a:pPr algn="l">
+              <a:lnSpc>
+                <a:spcPct val="100000"/>
+              </a:lnSpc>
+              <a:spcAft>
+                <a:spcPts val="0"/>
+              </a:spcAft>
+            </a:pPr>
+            <a:r>
+              <a:rPr sz="2400" b="0">
+                <a:solidFill>
+                  <a:srgbClr val="C2CEDA"/>
+                </a:solidFill>
+                <a:latin typeface="Arial"/>
+              </a:rPr>
+              <a:t>Department of Engineering Technology   ·   Middle Tennessee State University, Murfreesboro, TN, USA</a:t>
+            </a:r>
+          </a:p>
+        </p:txBody>
+      </p:sp>
+      <p:sp>
+        <p:nvSpPr>
+          <p:cNvPr id="8" name="TextBox 7"/>
+          <p:cNvSpPr txBox="1"/>
+          <p:nvPr/>
+        </p:nvSpPr>
+        <p:spPr>
+          <a:xfrm>
+            <a:off x="731520" y="4315968"/>
+            <a:ext cx="42428160" cy="365760"/>
+          </a:xfrm>
+          <a:prstGeom prst="rect">
+            <a:avLst/>
+          </a:prstGeom>
+          <a:noFill/>
+        </p:spPr>
+        <p:txBody>
+          <a:bodyPr wrap="square" lIns="0" rIns="0" tIns="0" bIns="0">
+            <a:spAutoFit/>
+          </a:bodyPr>
+          <a:lstStyle/>
+          <a:p>
+            <a:pPr algn="l">
+              <a:lnSpc>
+                <a:spcPct val="116000"/>
+              </a:lnSpc>
+              <a:spcAft>
+                <a:spcPts val="0"/>
+              </a:spcAft>
+            </a:pPr>
+            <a:r>
+              <a:rPr sz="3400" b="0">
+                <a:solidFill>
+                  <a:srgbClr val="1E293B"/>
+                </a:solidFill>
+                <a:latin typeface="Arial"/>
+              </a:rPr>
+              <a:t>Anyone can download a weed dataset this afternoon. Nobody can download the path from a robot in a Tennessee crop row to a trained checkpoint. We built that path, ran it unattended for fifteen rounds, and measured every stage of it, including the last one we have not closed.</a:t>
+            </a:r>
+          </a:p>
+        </p:txBody>
+      </p:sp>
       <p:pic>
         <p:nvPicPr>
-          <p:cNvPr id="12" name="Picture 11" descr="l_robots.png"/>
+          <p:cNvPr id="9" name="Picture 8" descr="n_system.png"/>
           <p:cNvPicPr>
             <a:picLocks noChangeAspect="1"/>
           </p:cNvPicPr>
           <p:nvPr/>
         </p:nvPicPr>
         <p:blipFill>
-          <a:blip r:embed="rId3"/>
+          <a:blip r:embed="rId2"/>
           <a:stretch>
             <a:fillRect/>
           </a:stretch>
         </p:blipFill>
         <p:spPr>
           <a:xfrm>
-            <a:off x="731520" y="6519672"/>
-            <a:ext cx="10607040" cy="2377440"/>
+            <a:off x="11704320" y="5623560"/>
+            <a:ext cx="20482560" cy="3383280"/>
           </a:xfrm>
           <a:prstGeom prst="rect">
             <a:avLst/>
@@ -3522,13 +3414,55 @@
       </p:pic>
       <p:sp>
         <p:nvSpPr>
-          <p:cNvPr id="13" name="TextBox 12"/>
-          <p:cNvSpPr txBox="1"/>
-          <p:nvPr/>
-        </p:nvSpPr>
-        <p:spPr>
-          <a:xfrm>
-            <a:off x="731520" y="9006840"/>
+          <p:cNvPr id="10" name="TextBox 9"/>
+          <p:cNvSpPr txBox="1"/>
+          <p:nvPr/>
+        </p:nvSpPr>
+        <p:spPr>
+          <a:xfrm>
+            <a:off x="11704320" y="9116568"/>
+            <a:ext cx="20482560" cy="365760"/>
+          </a:xfrm>
+          <a:prstGeom prst="rect">
+            <a:avLst/>
+          </a:prstGeom>
+          <a:noFill/>
+        </p:spPr>
+        <p:txBody>
+          <a:bodyPr wrap="square" lIns="0" rIns="0" tIns="0" bIns="0">
+            <a:spAutoFit/>
+          </a:bodyPr>
+          <a:lstStyle/>
+          <a:p>
+            <a:pPr algn="l">
+              <a:lnSpc>
+                <a:spcPct val="118000"/>
+              </a:lnSpc>
+              <a:spcAft>
+                <a:spcPts val="0"/>
+              </a:spcAft>
+            </a:pPr>
+            <a:r>
+              <a:rPr sz="1600" b="0">
+                <a:solidFill>
+                  <a:srgbClr val="556575"/>
+                </a:solidFill>
+                <a:latin typeface="Arial"/>
+              </a:rPr>
+              <a:t>Figure 1.  The path as built, from a camera in a crop row to a checkpoint on the cluster. Every stage has run. Three qualifications ride on it. The collector and trainer are paused after a stop-loss on 2026-08-29. The supervisor is advisory and nothing it says is applied. And the last link is not closed: no robot frame has entered training, because none of them is labelled yet.</a:t>
+            </a:r>
+          </a:p>
+        </p:txBody>
+      </p:sp>
+      <p:sp>
+        <p:nvSpPr>
+          <p:cNvPr id="11" name="TextBox 10"/>
+          <p:cNvSpPr txBox="1"/>
+          <p:nvPr/>
+        </p:nvSpPr>
+        <p:spPr>
+          <a:xfrm>
+            <a:off x="731520" y="5623560"/>
             <a:ext cx="10607040" cy="365760"/>
           </a:xfrm>
           <a:prstGeom prst="rect">
@@ -3544,117 +3478,33 @@
           <a:p>
             <a:pPr algn="l">
               <a:lnSpc>
-                <a:spcPct val="118000"/>
+                <a:spcPct val="95000"/>
               </a:lnSpc>
               <a:spcAft>
                 <a:spcPts val="0"/>
               </a:spcAft>
             </a:pPr>
             <a:r>
-              <a:rPr sz="1600" b="0">
-                <a:solidFill>
-                  <a:srgbClr val="556575"/>
-                </a:solidFill>
-                <a:latin typeface="Arial"/>
-              </a:rPr>
-              <a:t>Figure 2.  Frames as recorded, unenhanced. Robot 241 has sent 2,238 frames at 640 x 360 and 1 Hz, the laser cart 427, and 75 of the cart's were taken in a field. None of the 2,686 is labelled. The rectangle in the down camera is the cart's fixed work-zone overlay. It is drawn on every frame, including the ones with no vegetation in them.</a:t>
-            </a:r>
-          </a:p>
-        </p:txBody>
-      </p:sp>
-      <p:sp>
-        <p:nvSpPr>
-          <p:cNvPr id="14" name="TextBox 13"/>
-          <p:cNvSpPr txBox="1"/>
-          <p:nvPr/>
-        </p:nvSpPr>
-        <p:spPr>
-          <a:xfrm>
-            <a:off x="731520" y="10276840"/>
-            <a:ext cx="10607040" cy="365760"/>
-          </a:xfrm>
-          <a:prstGeom prst="rect">
-            <a:avLst/>
-          </a:prstGeom>
-          <a:noFill/>
-        </p:spPr>
-        <p:txBody>
-          <a:bodyPr wrap="square" lIns="0" rIns="0" tIns="0" bIns="0">
-            <a:spAutoFit/>
-          </a:bodyPr>
-          <a:lstStyle/>
-          <a:p>
-            <a:pPr algn="l">
-              <a:lnSpc>
-                <a:spcPct val="122000"/>
-              </a:lnSpc>
-              <a:spcAft>
-                <a:spcPts val="1200"/>
-              </a:spcAft>
-            </a:pPr>
-            <a:r>
-              <a:rPr sz="2000" b="0">
-                <a:solidFill>
-                  <a:srgbClr val="1E293B"/>
-                </a:solidFill>
-                <a:latin typeface="Arial"/>
-              </a:rPr>
-              <a:t>Robot 241 is a tracked rover that drives crop rows and streams frames, position and attitude over a cellular link. The laser cart carries the weeder itself: a galvanometer laser, a down camera over the work zone and a forward camera. Between them they have recorded 2,686 frames in 26 drives. None is labelled.</a:t>
-            </a:r>
-          </a:p>
-        </p:txBody>
-      </p:sp>
-      <p:sp>
-        <p:nvSpPr>
-          <p:cNvPr id="15" name="TextBox 14"/>
-          <p:cNvSpPr txBox="1"/>
-          <p:nvPr/>
-        </p:nvSpPr>
-        <p:spPr>
-          <a:xfrm>
-            <a:off x="32552640" y="5623560"/>
-            <a:ext cx="10607040" cy="365760"/>
-          </a:xfrm>
-          <a:prstGeom prst="rect">
-            <a:avLst/>
-          </a:prstGeom>
-          <a:noFill/>
-        </p:spPr>
-        <p:txBody>
-          <a:bodyPr wrap="square" lIns="0" rIns="0" tIns="0" bIns="0">
-            <a:spAutoFit/>
-          </a:bodyPr>
-          <a:lstStyle/>
-          <a:p>
-            <a:pPr algn="l">
-              <a:lnSpc>
-                <a:spcPct val="95000"/>
-              </a:lnSpc>
-              <a:spcAft>
-                <a:spcPts val="0"/>
-              </a:spcAft>
-            </a:pPr>
-            <a:r>
               <a:rPr sz="3400" b="1">
                 <a:solidFill>
                   <a:srgbClr val="14314E"/>
                 </a:solidFill>
                 <a:latin typeface="Arial"/>
               </a:rPr>
-              <a:t>What is on disk</a:t>
-            </a:r>
-          </a:p>
-        </p:txBody>
-      </p:sp>
-      <p:sp>
-        <p:nvSpPr>
-          <p:cNvPr id="16" name="Rectangle 15"/>
+              <a:t>The two vehicles</a:t>
+            </a:r>
+          </a:p>
+        </p:txBody>
+      </p:sp>
+      <p:sp>
+        <p:nvSpPr>
+          <p:cNvPr id="12" name="Rectangle 11"/>
           <p:cNvSpPr/>
           <p:nvPr/>
         </p:nvSpPr>
         <p:spPr>
           <a:xfrm>
-            <a:off x="32552640" y="6190488"/>
+            <a:off x="731520" y="6184900"/>
             <a:ext cx="10607040" cy="27432"/>
           </a:xfrm>
           <a:prstGeom prst="rect">
@@ -3690,15 +3540,39 @@
           </a:p>
         </p:txBody>
       </p:sp>
-      <p:sp>
-        <p:nvSpPr>
-          <p:cNvPr id="17" name="TextBox 16"/>
-          <p:cNvSpPr txBox="1"/>
-          <p:nvPr/>
-        </p:nvSpPr>
-        <p:spPr>
-          <a:xfrm>
-            <a:off x="32552640" y="6519672"/>
+      <p:pic>
+        <p:nvPicPr>
+          <p:cNvPr id="13" name="Picture 12" descr="l_robots.png"/>
+          <p:cNvPicPr>
+            <a:picLocks noChangeAspect="1"/>
+          </p:cNvPicPr>
+          <p:nvPr/>
+        </p:nvPicPr>
+        <p:blipFill>
+          <a:blip r:embed="rId3"/>
+          <a:stretch>
+            <a:fillRect/>
+          </a:stretch>
+        </p:blipFill>
+        <p:spPr>
+          <a:xfrm>
+            <a:off x="731520" y="6514084"/>
+            <a:ext cx="10607040" cy="2377440"/>
+          </a:xfrm>
+          <a:prstGeom prst="rect">
+            <a:avLst/>
+          </a:prstGeom>
+        </p:spPr>
+      </p:pic>
+      <p:sp>
+        <p:nvSpPr>
+          <p:cNvPr id="14" name="TextBox 13"/>
+          <p:cNvSpPr txBox="1"/>
+          <p:nvPr/>
+        </p:nvSpPr>
+        <p:spPr>
+          <a:xfrm>
+            <a:off x="731520" y="9001252"/>
             <a:ext cx="10607040" cy="365760"/>
           </a:xfrm>
           <a:prstGeom prst="rect">
@@ -3714,6 +3588,90 @@
           <a:p>
             <a:pPr algn="l">
               <a:lnSpc>
+                <a:spcPct val="118000"/>
+              </a:lnSpc>
+              <a:spcAft>
+                <a:spcPts val="0"/>
+              </a:spcAft>
+            </a:pPr>
+            <a:r>
+              <a:rPr sz="1600" b="0">
+                <a:solidFill>
+                  <a:srgbClr val="556575"/>
+                </a:solidFill>
+                <a:latin typeface="Arial"/>
+              </a:rPr>
+              <a:t>Figure 2.  Frames as recorded, unenhanced. Robot 241 has sent 2,238 frames at 640 x 360 and 1 Hz, the laser cart 427, and 75 of the cart's were taken in a field. None of the 2,686 is labelled. The rectangle in the down camera is the cart's fixed work-zone overlay. It is drawn on every frame, including the ones with no vegetation in them.</a:t>
+            </a:r>
+          </a:p>
+        </p:txBody>
+      </p:sp>
+      <p:sp>
+        <p:nvSpPr>
+          <p:cNvPr id="15" name="TextBox 14"/>
+          <p:cNvSpPr txBox="1"/>
+          <p:nvPr/>
+        </p:nvSpPr>
+        <p:spPr>
+          <a:xfrm>
+            <a:off x="731520" y="10271252"/>
+            <a:ext cx="10607040" cy="365760"/>
+          </a:xfrm>
+          <a:prstGeom prst="rect">
+            <a:avLst/>
+          </a:prstGeom>
+          <a:noFill/>
+        </p:spPr>
+        <p:txBody>
+          <a:bodyPr wrap="square" lIns="0" rIns="0" tIns="0" bIns="0">
+            <a:spAutoFit/>
+          </a:bodyPr>
+          <a:lstStyle/>
+          <a:p>
+            <a:pPr algn="l">
+              <a:lnSpc>
+                <a:spcPct val="122000"/>
+              </a:lnSpc>
+              <a:spcAft>
+                <a:spcPts val="1200"/>
+              </a:spcAft>
+            </a:pPr>
+            <a:r>
+              <a:rPr sz="2000" b="0">
+                <a:solidFill>
+                  <a:srgbClr val="1E293B"/>
+                </a:solidFill>
+                <a:latin typeface="Arial"/>
+              </a:rPr>
+              <a:t>Robot 241 is a tracked rover that drives crop rows and streams frames, position and attitude over a cellular link. The laser cart carries the weeder itself: a galvanometer laser, a down camera over the work zone and a forward camera. Between them they have recorded 2,686 frames in 26 drives. None is labelled.</a:t>
+            </a:r>
+          </a:p>
+        </p:txBody>
+      </p:sp>
+      <p:sp>
+        <p:nvSpPr>
+          <p:cNvPr id="16" name="TextBox 15"/>
+          <p:cNvSpPr txBox="1"/>
+          <p:nvPr/>
+        </p:nvSpPr>
+        <p:spPr>
+          <a:xfrm>
+            <a:off x="32552640" y="5623560"/>
+            <a:ext cx="10607040" cy="365760"/>
+          </a:xfrm>
+          <a:prstGeom prst="rect">
+            <a:avLst/>
+          </a:prstGeom>
+          <a:noFill/>
+        </p:spPr>
+        <p:txBody>
+          <a:bodyPr wrap="square" lIns="0" rIns="0" tIns="0" bIns="0">
+            <a:spAutoFit/>
+          </a:bodyPr>
+          <a:lstStyle/>
+          <a:p>
+            <a:pPr algn="l">
+              <a:lnSpc>
                 <a:spcPct val="95000"/>
               </a:lnSpc>
               <a:spcAft>
@@ -3721,369 +3679,33 @@
               </a:spcAft>
             </a:pPr>
             <a:r>
-              <a:rPr sz="6000" b="1">
-                <a:solidFill>
-                  <a:srgbClr val="1C6FB5"/>
-                </a:solidFill>
-                <a:latin typeface="Arial"/>
-              </a:rPr>
-              <a:t>2,686</a:t>
-            </a:r>
-          </a:p>
-        </p:txBody>
-      </p:sp>
-      <p:sp>
-        <p:nvSpPr>
-          <p:cNvPr id="18" name="TextBox 17"/>
-          <p:cNvSpPr txBox="1"/>
-          <p:nvPr/>
-        </p:nvSpPr>
-        <p:spPr>
-          <a:xfrm>
-            <a:off x="32552640" y="7296912"/>
-            <a:ext cx="10607040" cy="365760"/>
-          </a:xfrm>
-          <a:prstGeom prst="rect">
-            <a:avLst/>
-          </a:prstGeom>
-          <a:noFill/>
-        </p:spPr>
-        <p:txBody>
-          <a:bodyPr wrap="square" lIns="0" rIns="0" tIns="0" bIns="0">
-            <a:spAutoFit/>
-          </a:bodyPr>
-          <a:lstStyle/>
-          <a:p>
-            <a:pPr algn="l">
-              <a:lnSpc>
-                <a:spcPct val="122000"/>
-              </a:lnSpc>
-              <a:spcAft>
-                <a:spcPts val="200"/>
-              </a:spcAft>
-            </a:pPr>
-            <a:r>
-              <a:rPr sz="2000" b="0">
-                <a:solidFill>
-                  <a:srgbClr val="1E293B"/>
-                </a:solidFill>
-                <a:latin typeface="Arial"/>
-              </a:rPr>
-              <a:t>camera frames</a:t>
-            </a:r>
-          </a:p>
-        </p:txBody>
-      </p:sp>
-      <p:sp>
-        <p:nvSpPr>
-          <p:cNvPr id="19" name="TextBox 18"/>
-          <p:cNvSpPr txBox="1"/>
-          <p:nvPr/>
-        </p:nvSpPr>
-        <p:spPr>
-          <a:xfrm>
-            <a:off x="32552640" y="7632192"/>
-            <a:ext cx="10607040" cy="365760"/>
-          </a:xfrm>
-          <a:prstGeom prst="rect">
-            <a:avLst/>
-          </a:prstGeom>
-          <a:noFill/>
-        </p:spPr>
-        <p:txBody>
-          <a:bodyPr wrap="square" lIns="0" rIns="0" tIns="0" bIns="0">
-            <a:spAutoFit/>
-          </a:bodyPr>
-          <a:lstStyle/>
-          <a:p>
-            <a:pPr algn="l">
-              <a:lnSpc>
-                <a:spcPct val="122000"/>
-              </a:lnSpc>
-              <a:spcAft>
-                <a:spcPts val="0"/>
-              </a:spcAft>
-            </a:pPr>
-            <a:r>
-              <a:rPr sz="1600" b="0">
-                <a:solidFill>
-                  <a:srgbClr val="556575"/>
-                </a:solidFill>
-                <a:latin typeface="Arial"/>
-              </a:rPr>
-              <a:t>26 drives, 2 robots, 0 labelled</a:t>
-            </a:r>
-          </a:p>
-        </p:txBody>
-      </p:sp>
-      <p:sp>
-        <p:nvSpPr>
-          <p:cNvPr id="20" name="TextBox 19"/>
-          <p:cNvSpPr txBox="1"/>
-          <p:nvPr/>
-        </p:nvSpPr>
-        <p:spPr>
-          <a:xfrm>
-            <a:off x="32552640" y="8026400"/>
-            <a:ext cx="10607040" cy="365760"/>
-          </a:xfrm>
-          <a:prstGeom prst="rect">
-            <a:avLst/>
-          </a:prstGeom>
-          <a:noFill/>
-        </p:spPr>
-        <p:txBody>
-          <a:bodyPr wrap="square" lIns="0" rIns="0" tIns="0" bIns="0">
-            <a:spAutoFit/>
-          </a:bodyPr>
-          <a:lstStyle/>
-          <a:p>
-            <a:pPr algn="l">
-              <a:lnSpc>
-                <a:spcPct val="95000"/>
-              </a:lnSpc>
-              <a:spcAft>
-                <a:spcPts val="0"/>
-              </a:spcAft>
-            </a:pPr>
-            <a:r>
-              <a:rPr sz="6000" b="1">
-                <a:solidFill>
-                  <a:srgbClr val="1C6FB5"/>
-                </a:solidFill>
-                <a:latin typeface="Arial"/>
-              </a:rPr>
-              <a:t>91,955</a:t>
-            </a:r>
-          </a:p>
-        </p:txBody>
-      </p:sp>
-      <p:sp>
-        <p:nvSpPr>
-          <p:cNvPr id="21" name="TextBox 20"/>
-          <p:cNvSpPr txBox="1"/>
-          <p:nvPr/>
-        </p:nvSpPr>
-        <p:spPr>
-          <a:xfrm>
-            <a:off x="32552640" y="8803640"/>
-            <a:ext cx="10607040" cy="365760"/>
-          </a:xfrm>
-          <a:prstGeom prst="rect">
-            <a:avLst/>
-          </a:prstGeom>
-          <a:noFill/>
-        </p:spPr>
-        <p:txBody>
-          <a:bodyPr wrap="square" lIns="0" rIns="0" tIns="0" bIns="0">
-            <a:spAutoFit/>
-          </a:bodyPr>
-          <a:lstStyle/>
-          <a:p>
-            <a:pPr algn="l">
-              <a:lnSpc>
-                <a:spcPct val="122000"/>
-              </a:lnSpc>
-              <a:spcAft>
-                <a:spcPts val="200"/>
-              </a:spcAft>
-            </a:pPr>
-            <a:r>
-              <a:rPr sz="2000" b="0">
-                <a:solidFill>
-                  <a:srgbClr val="1E293B"/>
-                </a:solidFill>
-                <a:latin typeface="Arial"/>
-              </a:rPr>
-              <a:t>telemetry rows</a:t>
-            </a:r>
-          </a:p>
-        </p:txBody>
-      </p:sp>
-      <p:sp>
-        <p:nvSpPr>
-          <p:cNvPr id="22" name="TextBox 21"/>
-          <p:cNvSpPr txBox="1"/>
-          <p:nvPr/>
-        </p:nvSpPr>
-        <p:spPr>
-          <a:xfrm>
-            <a:off x="32552640" y="9138920"/>
-            <a:ext cx="10607040" cy="365760"/>
-          </a:xfrm>
-          <a:prstGeom prst="rect">
-            <a:avLst/>
-          </a:prstGeom>
-          <a:noFill/>
-        </p:spPr>
-        <p:txBody>
-          <a:bodyPr wrap="square" lIns="0" rIns="0" tIns="0" bIns="0">
-            <a:spAutoFit/>
-          </a:bodyPr>
-          <a:lstStyle/>
-          <a:p>
-            <a:pPr algn="l">
-              <a:lnSpc>
-                <a:spcPct val="122000"/>
-              </a:lnSpc>
-              <a:spcAft>
-                <a:spcPts val="0"/>
-              </a:spcAft>
-            </a:pPr>
-            <a:r>
-              <a:rPr sz="1600" b="0">
-                <a:solidFill>
-                  <a:srgbClr val="556575"/>
-                </a:solidFill>
-                <a:latin typeface="Arial"/>
-              </a:rPr>
-              <a:t>nine streams: GPS, two IMUs, motor, laser, control</a:t>
-            </a:r>
-          </a:p>
-        </p:txBody>
-      </p:sp>
-      <p:sp>
-        <p:nvSpPr>
-          <p:cNvPr id="23" name="TextBox 22"/>
-          <p:cNvSpPr txBox="1"/>
-          <p:nvPr/>
-        </p:nvSpPr>
-        <p:spPr>
-          <a:xfrm>
-            <a:off x="32552640" y="9533128"/>
-            <a:ext cx="10607040" cy="365760"/>
-          </a:xfrm>
-          <a:prstGeom prst="rect">
-            <a:avLst/>
-          </a:prstGeom>
-          <a:noFill/>
-        </p:spPr>
-        <p:txBody>
-          <a:bodyPr wrap="square" lIns="0" rIns="0" tIns="0" bIns="0">
-            <a:spAutoFit/>
-          </a:bodyPr>
-          <a:lstStyle/>
-          <a:p>
-            <a:pPr algn="l">
-              <a:lnSpc>
-                <a:spcPct val="95000"/>
-              </a:lnSpc>
-              <a:spcAft>
-                <a:spcPts val="0"/>
-              </a:spcAft>
-            </a:pPr>
-            <a:r>
-              <a:rPr sz="6000" b="1">
-                <a:solidFill>
-                  <a:srgbClr val="1C6FB5"/>
-                </a:solidFill>
-                <a:latin typeface="Arial"/>
-              </a:rPr>
-              <a:t>342 m</a:t>
-            </a:r>
-          </a:p>
-        </p:txBody>
-      </p:sp>
-      <p:sp>
-        <p:nvSpPr>
-          <p:cNvPr id="24" name="TextBox 23"/>
-          <p:cNvSpPr txBox="1"/>
-          <p:nvPr/>
-        </p:nvSpPr>
-        <p:spPr>
-          <a:xfrm>
-            <a:off x="32552640" y="10310368"/>
-            <a:ext cx="10607040" cy="365760"/>
-          </a:xfrm>
-          <a:prstGeom prst="rect">
-            <a:avLst/>
-          </a:prstGeom>
-          <a:noFill/>
-        </p:spPr>
-        <p:txBody>
-          <a:bodyPr wrap="square" lIns="0" rIns="0" tIns="0" bIns="0">
-            <a:spAutoFit/>
-          </a:bodyPr>
-          <a:lstStyle/>
-          <a:p>
-            <a:pPr algn="l">
-              <a:lnSpc>
-                <a:spcPct val="122000"/>
-              </a:lnSpc>
-              <a:spcAft>
-                <a:spcPts val="200"/>
-              </a:spcAft>
-            </a:pPr>
-            <a:r>
-              <a:rPr sz="2000" b="0">
-                <a:solidFill>
-                  <a:srgbClr val="1E293B"/>
-                </a:solidFill>
-                <a:latin typeface="Arial"/>
-              </a:rPr>
-              <a:t>of GPS track</a:t>
-            </a:r>
-          </a:p>
-        </p:txBody>
-      </p:sp>
-      <p:sp>
-        <p:nvSpPr>
-          <p:cNvPr id="25" name="TextBox 24"/>
-          <p:cNvSpPr txBox="1"/>
-          <p:nvPr/>
-        </p:nvSpPr>
-        <p:spPr>
-          <a:xfrm>
-            <a:off x="32552640" y="10645648"/>
-            <a:ext cx="10607040" cy="365760"/>
-          </a:xfrm>
-          <a:prstGeom prst="rect">
-            <a:avLst/>
-          </a:prstGeom>
-          <a:noFill/>
-        </p:spPr>
-        <p:txBody>
-          <a:bodyPr wrap="square" lIns="0" rIns="0" tIns="0" bIns="0">
-            <a:spAutoFit/>
-          </a:bodyPr>
-          <a:lstStyle/>
-          <a:p>
-            <a:pPr algn="l">
-              <a:lnSpc>
-                <a:spcPct val="122000"/>
-              </a:lnSpc>
-              <a:spcAft>
-                <a:spcPts val="0"/>
-              </a:spcAft>
-            </a:pPr>
-            <a:r>
-              <a:rPr sz="1600" b="0">
-                <a:solidFill>
-                  <a:srgbClr val="556575"/>
-                </a:solidFill>
-                <a:latin typeface="Arial"/>
-              </a:rPr>
-              <a:t>1,502 fixes over 18 drives; the longest single pass is 141 m</a:t>
-            </a:r>
-          </a:p>
-        </p:txBody>
-      </p:sp>
-      <p:sp>
-        <p:nvSpPr>
-          <p:cNvPr id="26" name="Rectangle 25"/>
+              <a:rPr sz="3400" b="1">
+                <a:solidFill>
+                  <a:srgbClr val="14314E"/>
+                </a:solidFill>
+                <a:latin typeface="Arial"/>
+              </a:rPr>
+              <a:t>What is on disk</a:t>
+            </a:r>
+          </a:p>
+        </p:txBody>
+      </p:sp>
+      <p:sp>
+        <p:nvSpPr>
+          <p:cNvPr id="17" name="Rectangle 16"/>
           <p:cNvSpPr/>
           <p:nvPr/>
         </p:nvSpPr>
         <p:spPr>
           <a:xfrm>
-            <a:off x="32552640" y="11039856"/>
-            <a:ext cx="27432" cy="0"/>
+            <a:off x="32552640" y="6184900"/>
+            <a:ext cx="10607040" cy="27432"/>
           </a:xfrm>
           <a:prstGeom prst="rect">
             <a:avLst/>
           </a:prstGeom>
           <a:solidFill>
-            <a:srgbClr val="C2CEDA"/>
+            <a:srgbClr val="1C6FB5"/>
           </a:solidFill>
           <a:ln>
             <a:noFill/>
@@ -4114,13 +3736,391 @@
       </p:sp>
       <p:sp>
         <p:nvSpPr>
+          <p:cNvPr id="18" name="TextBox 17"/>
+          <p:cNvSpPr txBox="1"/>
+          <p:nvPr/>
+        </p:nvSpPr>
+        <p:spPr>
+          <a:xfrm>
+            <a:off x="32552640" y="6514084"/>
+            <a:ext cx="10607040" cy="365760"/>
+          </a:xfrm>
+          <a:prstGeom prst="rect">
+            <a:avLst/>
+          </a:prstGeom>
+          <a:noFill/>
+        </p:spPr>
+        <p:txBody>
+          <a:bodyPr wrap="square" lIns="0" rIns="0" tIns="0" bIns="0">
+            <a:spAutoFit/>
+          </a:bodyPr>
+          <a:lstStyle/>
+          <a:p>
+            <a:pPr algn="l">
+              <a:lnSpc>
+                <a:spcPct val="95000"/>
+              </a:lnSpc>
+              <a:spcAft>
+                <a:spcPts val="0"/>
+              </a:spcAft>
+            </a:pPr>
+            <a:r>
+              <a:rPr sz="6000" b="1">
+                <a:solidFill>
+                  <a:srgbClr val="1C6FB5"/>
+                </a:solidFill>
+                <a:latin typeface="Arial"/>
+              </a:rPr>
+              <a:t>2,686</a:t>
+            </a:r>
+          </a:p>
+        </p:txBody>
+      </p:sp>
+      <p:sp>
+        <p:nvSpPr>
+          <p:cNvPr id="19" name="TextBox 18"/>
+          <p:cNvSpPr txBox="1"/>
+          <p:nvPr/>
+        </p:nvSpPr>
+        <p:spPr>
+          <a:xfrm>
+            <a:off x="32552640" y="7291324"/>
+            <a:ext cx="10607040" cy="365760"/>
+          </a:xfrm>
+          <a:prstGeom prst="rect">
+            <a:avLst/>
+          </a:prstGeom>
+          <a:noFill/>
+        </p:spPr>
+        <p:txBody>
+          <a:bodyPr wrap="square" lIns="0" rIns="0" tIns="0" bIns="0">
+            <a:spAutoFit/>
+          </a:bodyPr>
+          <a:lstStyle/>
+          <a:p>
+            <a:pPr algn="l">
+              <a:lnSpc>
+                <a:spcPct val="122000"/>
+              </a:lnSpc>
+              <a:spcAft>
+                <a:spcPts val="200"/>
+              </a:spcAft>
+            </a:pPr>
+            <a:r>
+              <a:rPr sz="2000" b="0">
+                <a:solidFill>
+                  <a:srgbClr val="1E293B"/>
+                </a:solidFill>
+                <a:latin typeface="Arial"/>
+              </a:rPr>
+              <a:t>camera frames</a:t>
+            </a:r>
+          </a:p>
+        </p:txBody>
+      </p:sp>
+      <p:sp>
+        <p:nvSpPr>
+          <p:cNvPr id="20" name="TextBox 19"/>
+          <p:cNvSpPr txBox="1"/>
+          <p:nvPr/>
+        </p:nvSpPr>
+        <p:spPr>
+          <a:xfrm>
+            <a:off x="32552640" y="7626604"/>
+            <a:ext cx="10607040" cy="365760"/>
+          </a:xfrm>
+          <a:prstGeom prst="rect">
+            <a:avLst/>
+          </a:prstGeom>
+          <a:noFill/>
+        </p:spPr>
+        <p:txBody>
+          <a:bodyPr wrap="square" lIns="0" rIns="0" tIns="0" bIns="0">
+            <a:spAutoFit/>
+          </a:bodyPr>
+          <a:lstStyle/>
+          <a:p>
+            <a:pPr algn="l">
+              <a:lnSpc>
+                <a:spcPct val="122000"/>
+              </a:lnSpc>
+              <a:spcAft>
+                <a:spcPts val="0"/>
+              </a:spcAft>
+            </a:pPr>
+            <a:r>
+              <a:rPr sz="1600" b="0">
+                <a:solidFill>
+                  <a:srgbClr val="556575"/>
+                </a:solidFill>
+                <a:latin typeface="Arial"/>
+              </a:rPr>
+              <a:t>26 drives, 2 robots, 0 labelled</a:t>
+            </a:r>
+          </a:p>
+        </p:txBody>
+      </p:sp>
+      <p:sp>
+        <p:nvSpPr>
+          <p:cNvPr id="21" name="TextBox 20"/>
+          <p:cNvSpPr txBox="1"/>
+          <p:nvPr/>
+        </p:nvSpPr>
+        <p:spPr>
+          <a:xfrm>
+            <a:off x="32552640" y="8020812"/>
+            <a:ext cx="10607040" cy="365760"/>
+          </a:xfrm>
+          <a:prstGeom prst="rect">
+            <a:avLst/>
+          </a:prstGeom>
+          <a:noFill/>
+        </p:spPr>
+        <p:txBody>
+          <a:bodyPr wrap="square" lIns="0" rIns="0" tIns="0" bIns="0">
+            <a:spAutoFit/>
+          </a:bodyPr>
+          <a:lstStyle/>
+          <a:p>
+            <a:pPr algn="l">
+              <a:lnSpc>
+                <a:spcPct val="95000"/>
+              </a:lnSpc>
+              <a:spcAft>
+                <a:spcPts val="0"/>
+              </a:spcAft>
+            </a:pPr>
+            <a:r>
+              <a:rPr sz="6000" b="1">
+                <a:solidFill>
+                  <a:srgbClr val="1C6FB5"/>
+                </a:solidFill>
+                <a:latin typeface="Arial"/>
+              </a:rPr>
+              <a:t>91,955</a:t>
+            </a:r>
+          </a:p>
+        </p:txBody>
+      </p:sp>
+      <p:sp>
+        <p:nvSpPr>
+          <p:cNvPr id="22" name="TextBox 21"/>
+          <p:cNvSpPr txBox="1"/>
+          <p:nvPr/>
+        </p:nvSpPr>
+        <p:spPr>
+          <a:xfrm>
+            <a:off x="32552640" y="8798052"/>
+            <a:ext cx="10607040" cy="365760"/>
+          </a:xfrm>
+          <a:prstGeom prst="rect">
+            <a:avLst/>
+          </a:prstGeom>
+          <a:noFill/>
+        </p:spPr>
+        <p:txBody>
+          <a:bodyPr wrap="square" lIns="0" rIns="0" tIns="0" bIns="0">
+            <a:spAutoFit/>
+          </a:bodyPr>
+          <a:lstStyle/>
+          <a:p>
+            <a:pPr algn="l">
+              <a:lnSpc>
+                <a:spcPct val="122000"/>
+              </a:lnSpc>
+              <a:spcAft>
+                <a:spcPts val="200"/>
+              </a:spcAft>
+            </a:pPr>
+            <a:r>
+              <a:rPr sz="2000" b="0">
+                <a:solidFill>
+                  <a:srgbClr val="1E293B"/>
+                </a:solidFill>
+                <a:latin typeface="Arial"/>
+              </a:rPr>
+              <a:t>telemetry rows</a:t>
+            </a:r>
+          </a:p>
+        </p:txBody>
+      </p:sp>
+      <p:sp>
+        <p:nvSpPr>
+          <p:cNvPr id="23" name="TextBox 22"/>
+          <p:cNvSpPr txBox="1"/>
+          <p:nvPr/>
+        </p:nvSpPr>
+        <p:spPr>
+          <a:xfrm>
+            <a:off x="32552640" y="9133332"/>
+            <a:ext cx="10607040" cy="365760"/>
+          </a:xfrm>
+          <a:prstGeom prst="rect">
+            <a:avLst/>
+          </a:prstGeom>
+          <a:noFill/>
+        </p:spPr>
+        <p:txBody>
+          <a:bodyPr wrap="square" lIns="0" rIns="0" tIns="0" bIns="0">
+            <a:spAutoFit/>
+          </a:bodyPr>
+          <a:lstStyle/>
+          <a:p>
+            <a:pPr algn="l">
+              <a:lnSpc>
+                <a:spcPct val="122000"/>
+              </a:lnSpc>
+              <a:spcAft>
+                <a:spcPts val="0"/>
+              </a:spcAft>
+            </a:pPr>
+            <a:r>
+              <a:rPr sz="1600" b="0">
+                <a:solidFill>
+                  <a:srgbClr val="556575"/>
+                </a:solidFill>
+                <a:latin typeface="Arial"/>
+              </a:rPr>
+              <a:t>nine streams: GPS, two IMUs, motor, laser, control</a:t>
+            </a:r>
+          </a:p>
+        </p:txBody>
+      </p:sp>
+      <p:sp>
+        <p:nvSpPr>
+          <p:cNvPr id="24" name="TextBox 23"/>
+          <p:cNvSpPr txBox="1"/>
+          <p:nvPr/>
+        </p:nvSpPr>
+        <p:spPr>
+          <a:xfrm>
+            <a:off x="32552640" y="9527540"/>
+            <a:ext cx="10607040" cy="365760"/>
+          </a:xfrm>
+          <a:prstGeom prst="rect">
+            <a:avLst/>
+          </a:prstGeom>
+          <a:noFill/>
+        </p:spPr>
+        <p:txBody>
+          <a:bodyPr wrap="square" lIns="0" rIns="0" tIns="0" bIns="0">
+            <a:spAutoFit/>
+          </a:bodyPr>
+          <a:lstStyle/>
+          <a:p>
+            <a:pPr algn="l">
+              <a:lnSpc>
+                <a:spcPct val="95000"/>
+              </a:lnSpc>
+              <a:spcAft>
+                <a:spcPts val="0"/>
+              </a:spcAft>
+            </a:pPr>
+            <a:r>
+              <a:rPr sz="6000" b="1">
+                <a:solidFill>
+                  <a:srgbClr val="1C6FB5"/>
+                </a:solidFill>
+                <a:latin typeface="Arial"/>
+              </a:rPr>
+              <a:t>342 m</a:t>
+            </a:r>
+          </a:p>
+        </p:txBody>
+      </p:sp>
+      <p:sp>
+        <p:nvSpPr>
+          <p:cNvPr id="25" name="TextBox 24"/>
+          <p:cNvSpPr txBox="1"/>
+          <p:nvPr/>
+        </p:nvSpPr>
+        <p:spPr>
+          <a:xfrm>
+            <a:off x="32552640" y="10304780"/>
+            <a:ext cx="10607040" cy="365760"/>
+          </a:xfrm>
+          <a:prstGeom prst="rect">
+            <a:avLst/>
+          </a:prstGeom>
+          <a:noFill/>
+        </p:spPr>
+        <p:txBody>
+          <a:bodyPr wrap="square" lIns="0" rIns="0" tIns="0" bIns="0">
+            <a:spAutoFit/>
+          </a:bodyPr>
+          <a:lstStyle/>
+          <a:p>
+            <a:pPr algn="l">
+              <a:lnSpc>
+                <a:spcPct val="122000"/>
+              </a:lnSpc>
+              <a:spcAft>
+                <a:spcPts val="200"/>
+              </a:spcAft>
+            </a:pPr>
+            <a:r>
+              <a:rPr sz="2000" b="0">
+                <a:solidFill>
+                  <a:srgbClr val="1E293B"/>
+                </a:solidFill>
+                <a:latin typeface="Arial"/>
+              </a:rPr>
+              <a:t>of GPS track</a:t>
+            </a:r>
+          </a:p>
+        </p:txBody>
+      </p:sp>
+      <p:sp>
+        <p:nvSpPr>
+          <p:cNvPr id="26" name="TextBox 25"/>
+          <p:cNvSpPr txBox="1"/>
+          <p:nvPr/>
+        </p:nvSpPr>
+        <p:spPr>
+          <a:xfrm>
+            <a:off x="32552640" y="10640060"/>
+            <a:ext cx="10607040" cy="365760"/>
+          </a:xfrm>
+          <a:prstGeom prst="rect">
+            <a:avLst/>
+          </a:prstGeom>
+          <a:noFill/>
+        </p:spPr>
+        <p:txBody>
+          <a:bodyPr wrap="square" lIns="0" rIns="0" tIns="0" bIns="0">
+            <a:spAutoFit/>
+          </a:bodyPr>
+          <a:lstStyle/>
+          <a:p>
+            <a:pPr algn="l">
+              <a:lnSpc>
+                <a:spcPct val="122000"/>
+              </a:lnSpc>
+              <a:spcAft>
+                <a:spcPts val="0"/>
+              </a:spcAft>
+            </a:pPr>
+            <a:r>
+              <a:rPr sz="1600" b="0">
+                <a:solidFill>
+                  <a:srgbClr val="556575"/>
+                </a:solidFill>
+                <a:latin typeface="Arial"/>
+              </a:rPr>
+              <a:t>1,502 fixes over 18 drives; the longest single pass is 141 m</a:t>
+            </a:r>
+          </a:p>
+        </p:txBody>
+      </p:sp>
+      <p:sp>
+        <p:nvSpPr>
           <p:cNvPr id="27" name="TextBox 26"/>
           <p:cNvSpPr txBox="1"/>
           <p:nvPr/>
         </p:nvSpPr>
         <p:spPr>
           <a:xfrm>
-            <a:off x="32790384" y="11039856"/>
+            <a:off x="32790384" y="11034268"/>
             <a:ext cx="10369296" cy="365760"/>
           </a:xfrm>
           <a:prstGeom prst="rect">
@@ -4162,7 +4162,7 @@
         </p:nvSpPr>
         <p:spPr>
           <a:xfrm>
-            <a:off x="32790384" y="11387836"/>
+            <a:off x="32790384" y="11382248"/>
             <a:ext cx="10369296" cy="365760"/>
           </a:xfrm>
           <a:prstGeom prst="rect">
@@ -4204,7 +4204,7 @@
         </p:nvSpPr>
         <p:spPr>
           <a:xfrm>
-            <a:off x="32552640" y="11039856"/>
+            <a:off x="32552640" y="11034268"/>
             <a:ext cx="27432" cy="843788"/>
           </a:xfrm>
           <a:prstGeom prst="rect">
@@ -4248,7 +4248,7 @@
         </p:nvSpPr>
         <p:spPr>
           <a:xfrm>
-            <a:off x="731520" y="12468860"/>
+            <a:off x="731520" y="12463272"/>
             <a:ext cx="10607040" cy="365760"/>
           </a:xfrm>
           <a:prstGeom prst="rect">
@@ -4290,7 +4290,7 @@
         </p:nvSpPr>
         <p:spPr>
           <a:xfrm>
-            <a:off x="731520" y="13035788"/>
+            <a:off x="731520" y="13024612"/>
             <a:ext cx="10607040" cy="27432"/>
           </a:xfrm>
           <a:prstGeom prst="rect">
@@ -4334,7 +4334,7 @@
         </p:nvSpPr>
         <p:spPr>
           <a:xfrm>
-            <a:off x="731520" y="13364972"/>
+            <a:off x="731520" y="13353796"/>
             <a:ext cx="10607040" cy="365760"/>
           </a:xfrm>
           <a:prstGeom prst="rect">
@@ -4376,7 +4376,7 @@
         </p:nvSpPr>
         <p:spPr>
           <a:xfrm>
-            <a:off x="731520" y="15066772"/>
+            <a:off x="731520" y="15055596"/>
             <a:ext cx="10607040" cy="365760"/>
           </a:xfrm>
           <a:prstGeom prst="rect">
@@ -4426,7 +4426,7 @@
         </p:blipFill>
         <p:spPr>
           <a:xfrm>
-            <a:off x="731520" y="15487396"/>
+            <a:off x="731520" y="15476220"/>
             <a:ext cx="10607040" cy="4023360"/>
           </a:xfrm>
           <a:prstGeom prst="rect">
@@ -4442,7 +4442,7 @@
         </p:nvSpPr>
         <p:spPr>
           <a:xfrm>
-            <a:off x="731520" y="19620484"/>
+            <a:off x="731520" y="19609308"/>
             <a:ext cx="10607040" cy="365760"/>
           </a:xfrm>
           <a:prstGeom prst="rect">
@@ -4484,7 +4484,7 @@
         </p:nvSpPr>
         <p:spPr>
           <a:xfrm>
-            <a:off x="11704320" y="12468860"/>
+            <a:off x="11704320" y="12463272"/>
             <a:ext cx="20482560" cy="365760"/>
           </a:xfrm>
           <a:prstGeom prst="rect">
@@ -4526,7 +4526,7 @@
         </p:nvSpPr>
         <p:spPr>
           <a:xfrm>
-            <a:off x="11704320" y="13035788"/>
+            <a:off x="11704320" y="13024612"/>
             <a:ext cx="20482560" cy="27432"/>
           </a:xfrm>
           <a:prstGeom prst="rect">
@@ -4570,7 +4570,7 @@
         </p:nvSpPr>
         <p:spPr>
           <a:xfrm>
-            <a:off x="11704320" y="13364972"/>
+            <a:off x="11704320" y="13353796"/>
             <a:ext cx="20482560" cy="365760"/>
           </a:xfrm>
           <a:prstGeom prst="rect">
@@ -4620,7 +4620,7 @@
         </p:blipFill>
         <p:spPr>
           <a:xfrm>
-            <a:off x="11704320" y="14137132"/>
+            <a:off x="11704320" y="14125956"/>
             <a:ext cx="20482560" cy="4663440"/>
           </a:xfrm>
           <a:prstGeom prst="rect">
@@ -4636,7 +4636,7 @@
         </p:nvSpPr>
         <p:spPr>
           <a:xfrm>
-            <a:off x="11704320" y="18910300"/>
+            <a:off x="11704320" y="18899124"/>
             <a:ext cx="20482560" cy="365760"/>
           </a:xfrm>
           <a:prstGeom prst="rect">
@@ -4678,7 +4678,7 @@
         </p:nvSpPr>
         <p:spPr>
           <a:xfrm>
-            <a:off x="11704320" y="19940524"/>
+            <a:off x="11704320" y="19929348"/>
             <a:ext cx="20482560" cy="365760"/>
           </a:xfrm>
           <a:prstGeom prst="rect">
@@ -4720,7 +4720,7 @@
         </p:nvSpPr>
         <p:spPr>
           <a:xfrm>
-            <a:off x="32552640" y="12468860"/>
+            <a:off x="32552640" y="12463272"/>
             <a:ext cx="10607040" cy="365760"/>
           </a:xfrm>
           <a:prstGeom prst="rect">
@@ -4762,7 +4762,7 @@
         </p:nvSpPr>
         <p:spPr>
           <a:xfrm>
-            <a:off x="32552640" y="13035788"/>
+            <a:off x="32552640" y="13024612"/>
             <a:ext cx="10607040" cy="27432"/>
           </a:xfrm>
           <a:prstGeom prst="rect">
@@ -4806,7 +4806,7 @@
         </p:nvSpPr>
         <p:spPr>
           <a:xfrm>
-            <a:off x="32552640" y="13364972"/>
+            <a:off x="32552640" y="13353796"/>
             <a:ext cx="10607040" cy="23774"/>
           </a:xfrm>
           <a:prstGeom prst="rect">
@@ -4850,7 +4850,7 @@
         </p:nvSpPr>
         <p:spPr>
           <a:xfrm>
-            <a:off x="32552640" y="13483844"/>
+            <a:off x="32552640" y="13472668"/>
             <a:ext cx="4667097" cy="365760"/>
           </a:xfrm>
           <a:prstGeom prst="rect">
@@ -4892,7 +4892,7 @@
         </p:nvSpPr>
         <p:spPr>
           <a:xfrm>
-            <a:off x="37219737" y="13483844"/>
+            <a:off x="37219737" y="13472668"/>
             <a:ext cx="4242816" cy="365760"/>
           </a:xfrm>
           <a:prstGeom prst="rect">
@@ -4934,7 +4934,7 @@
         </p:nvSpPr>
         <p:spPr>
           <a:xfrm>
-            <a:off x="41462553" y="13483844"/>
+            <a:off x="41462553" y="13472668"/>
             <a:ext cx="1697126" cy="365760"/>
           </a:xfrm>
           <a:prstGeom prst="rect">
@@ -4976,7 +4976,7 @@
         </p:nvSpPr>
         <p:spPr>
           <a:xfrm>
-            <a:off x="32552640" y="13849604"/>
+            <a:off x="32552640" y="13838428"/>
             <a:ext cx="10607040" cy="14630"/>
           </a:xfrm>
           <a:prstGeom prst="rect">
@@ -5020,7 +5020,7 @@
         </p:nvSpPr>
         <p:spPr>
           <a:xfrm>
-            <a:off x="32552640" y="13959332"/>
+            <a:off x="32552640" y="13948156"/>
             <a:ext cx="4667097" cy="365760"/>
           </a:xfrm>
           <a:prstGeom prst="rect">
@@ -5062,7 +5062,7 @@
         </p:nvSpPr>
         <p:spPr>
           <a:xfrm>
-            <a:off x="37219737" y="13959332"/>
+            <a:off x="37219737" y="13948156"/>
             <a:ext cx="4242816" cy="365760"/>
           </a:xfrm>
           <a:prstGeom prst="rect">
@@ -5104,7 +5104,7 @@
         </p:nvSpPr>
         <p:spPr>
           <a:xfrm>
-            <a:off x="41462553" y="13959332"/>
+            <a:off x="41462553" y="13948156"/>
             <a:ext cx="1697126" cy="365760"/>
           </a:xfrm>
           <a:prstGeom prst="rect">
@@ -5146,7 +5146,7 @@
         </p:nvSpPr>
         <p:spPr>
           <a:xfrm>
-            <a:off x="32552640" y="14361668"/>
+            <a:off x="32552640" y="14350492"/>
             <a:ext cx="4667097" cy="365760"/>
           </a:xfrm>
           <a:prstGeom prst="rect">
@@ -5188,7 +5188,7 @@
         </p:nvSpPr>
         <p:spPr>
           <a:xfrm>
-            <a:off x="37219737" y="14361668"/>
+            <a:off x="37219737" y="14350492"/>
             <a:ext cx="4242816" cy="365760"/>
           </a:xfrm>
           <a:prstGeom prst="rect">
@@ -5230,7 +5230,7 @@
         </p:nvSpPr>
         <p:spPr>
           <a:xfrm>
-            <a:off x="41462553" y="14361668"/>
+            <a:off x="41462553" y="14350492"/>
             <a:ext cx="1697126" cy="365760"/>
           </a:xfrm>
           <a:prstGeom prst="rect">
@@ -5272,7 +5272,7 @@
         </p:nvSpPr>
         <p:spPr>
           <a:xfrm>
-            <a:off x="32552640" y="14764004"/>
+            <a:off x="32552640" y="14752828"/>
             <a:ext cx="4667097" cy="365760"/>
           </a:xfrm>
           <a:prstGeom prst="rect">
@@ -5314,7 +5314,7 @@
         </p:nvSpPr>
         <p:spPr>
           <a:xfrm>
-            <a:off x="37219737" y="14764004"/>
+            <a:off x="37219737" y="14752828"/>
             <a:ext cx="4242816" cy="365760"/>
           </a:xfrm>
           <a:prstGeom prst="rect">
@@ -5356,7 +5356,7 @@
         </p:nvSpPr>
         <p:spPr>
           <a:xfrm>
-            <a:off x="41462553" y="14764004"/>
+            <a:off x="41462553" y="14752828"/>
             <a:ext cx="1697126" cy="365760"/>
           </a:xfrm>
           <a:prstGeom prst="rect">
@@ -5398,7 +5398,7 @@
         </p:nvSpPr>
         <p:spPr>
           <a:xfrm>
-            <a:off x="32552640" y="15166340"/>
+            <a:off x="32552640" y="15155164"/>
             <a:ext cx="4667097" cy="365760"/>
           </a:xfrm>
           <a:prstGeom prst="rect">
@@ -5440,7 +5440,7 @@
         </p:nvSpPr>
         <p:spPr>
           <a:xfrm>
-            <a:off x="37219737" y="15166340"/>
+            <a:off x="37219737" y="15155164"/>
             <a:ext cx="4242816" cy="365760"/>
           </a:xfrm>
           <a:prstGeom prst="rect">
@@ -5482,7 +5482,7 @@
         </p:nvSpPr>
         <p:spPr>
           <a:xfrm>
-            <a:off x="41462553" y="15166340"/>
+            <a:off x="41462553" y="15155164"/>
             <a:ext cx="1697126" cy="365760"/>
           </a:xfrm>
           <a:prstGeom prst="rect">
@@ -5524,7 +5524,7 @@
         </p:nvSpPr>
         <p:spPr>
           <a:xfrm>
-            <a:off x="32552640" y="15596108"/>
+            <a:off x="32552640" y="15584932"/>
             <a:ext cx="10607040" cy="23774"/>
           </a:xfrm>
           <a:prstGeom prst="rect">
@@ -5568,7 +5568,7 @@
         </p:nvSpPr>
         <p:spPr>
           <a:xfrm>
-            <a:off x="32552640" y="15861284"/>
+            <a:off x="32552640" y="15850108"/>
             <a:ext cx="10607040" cy="365760"/>
           </a:xfrm>
           <a:prstGeom prst="rect">
@@ -5610,7 +5610,7 @@
         </p:nvSpPr>
         <p:spPr>
           <a:xfrm>
-            <a:off x="11704320" y="21753068"/>
+            <a:off x="11704320" y="21741892"/>
             <a:ext cx="20482560" cy="365760"/>
           </a:xfrm>
           <a:prstGeom prst="rect">
@@ -5652,7 +5652,7 @@
         </p:nvSpPr>
         <p:spPr>
           <a:xfrm>
-            <a:off x="11704320" y="22319996"/>
+            <a:off x="11704320" y="22303232"/>
             <a:ext cx="20482560" cy="27432"/>
           </a:xfrm>
           <a:prstGeom prst="rect">
@@ -5704,7 +5704,7 @@
         </p:blipFill>
         <p:spPr>
           <a:xfrm>
-            <a:off x="11704320" y="22649180"/>
+            <a:off x="11704320" y="22632416"/>
             <a:ext cx="20482560" cy="3749040"/>
           </a:xfrm>
           <a:prstGeom prst="rect">
@@ -5720,7 +5720,7 @@
         </p:nvSpPr>
         <p:spPr>
           <a:xfrm>
-            <a:off x="11704320" y="26507948"/>
+            <a:off x="11704320" y="26491184"/>
             <a:ext cx="20482560" cy="365760"/>
           </a:xfrm>
           <a:prstGeom prst="rect">
@@ -5762,7 +5762,7 @@
         </p:nvSpPr>
         <p:spPr>
           <a:xfrm>
-            <a:off x="731520" y="21753068"/>
+            <a:off x="731520" y="21741892"/>
             <a:ext cx="10607040" cy="365760"/>
           </a:xfrm>
           <a:prstGeom prst="rect">
@@ -5804,7 +5804,7 @@
         </p:nvSpPr>
         <p:spPr>
           <a:xfrm>
-            <a:off x="731520" y="22319996"/>
+            <a:off x="731520" y="22303232"/>
             <a:ext cx="10607040" cy="27432"/>
           </a:xfrm>
           <a:prstGeom prst="rect">
@@ -5856,7 +5856,7 @@
         </p:blipFill>
         <p:spPr>
           <a:xfrm>
-            <a:off x="731520" y="22649180"/>
+            <a:off x="731520" y="22632416"/>
             <a:ext cx="10607040" cy="2468880"/>
           </a:xfrm>
           <a:prstGeom prst="rect">
@@ -5872,7 +5872,7 @@
         </p:nvSpPr>
         <p:spPr>
           <a:xfrm>
-            <a:off x="731520" y="25227788"/>
+            <a:off x="731520" y="25211024"/>
             <a:ext cx="10607040" cy="365760"/>
           </a:xfrm>
           <a:prstGeom prst="rect">
@@ -5914,7 +5914,7 @@
         </p:nvSpPr>
         <p:spPr>
           <a:xfrm>
-            <a:off x="32552640" y="21753068"/>
+            <a:off x="32552640" y="21741892"/>
             <a:ext cx="10607040" cy="365760"/>
           </a:xfrm>
           <a:prstGeom prst="rect">
@@ -5956,7 +5956,7 @@
         </p:nvSpPr>
         <p:spPr>
           <a:xfrm>
-            <a:off x="32552640" y="22319996"/>
+            <a:off x="32552640" y="22303232"/>
             <a:ext cx="10607040" cy="27432"/>
           </a:xfrm>
           <a:prstGeom prst="rect">
@@ -6000,7 +6000,7 @@
         </p:nvSpPr>
         <p:spPr>
           <a:xfrm>
-            <a:off x="32552640" y="22649180"/>
+            <a:off x="32552640" y="22632416"/>
             <a:ext cx="10607040" cy="365760"/>
           </a:xfrm>
           <a:prstGeom prst="rect">
@@ -6042,7 +6042,7 @@
         </p:nvSpPr>
         <p:spPr>
           <a:xfrm>
-            <a:off x="32552640" y="25098756"/>
+            <a:off x="32552640" y="25081992"/>
             <a:ext cx="10607040" cy="23774"/>
           </a:xfrm>
           <a:prstGeom prst="rect">
@@ -6086,7 +6086,7 @@
         </p:nvSpPr>
         <p:spPr>
           <a:xfrm>
-            <a:off x="32552640" y="25217628"/>
+            <a:off x="32552640" y="25200864"/>
             <a:ext cx="4030675" cy="365760"/>
           </a:xfrm>
           <a:prstGeom prst="rect">
@@ -6128,7 +6128,7 @@
         </p:nvSpPr>
         <p:spPr>
           <a:xfrm>
-            <a:off x="36583315" y="25217628"/>
+            <a:off x="36583315" y="25200864"/>
             <a:ext cx="2227478" cy="365760"/>
           </a:xfrm>
           <a:prstGeom prst="rect">
@@ -6170,7 +6170,7 @@
         </p:nvSpPr>
         <p:spPr>
           <a:xfrm>
-            <a:off x="38810793" y="25217628"/>
+            <a:off x="38810793" y="25200864"/>
             <a:ext cx="2227478" cy="365760"/>
           </a:xfrm>
           <a:prstGeom prst="rect">
@@ -6212,7 +6212,7 @@
         </p:nvSpPr>
         <p:spPr>
           <a:xfrm>
-            <a:off x="41038272" y="25217628"/>
+            <a:off x="41038272" y="25200864"/>
             <a:ext cx="2121408" cy="365760"/>
           </a:xfrm>
           <a:prstGeom prst="rect">
@@ -6254,7 +6254,7 @@
         </p:nvSpPr>
         <p:spPr>
           <a:xfrm>
-            <a:off x="32552640" y="25583388"/>
+            <a:off x="32552640" y="25566624"/>
             <a:ext cx="10607040" cy="14630"/>
           </a:xfrm>
           <a:prstGeom prst="rect">
@@ -6298,7 +6298,7 @@
         </p:nvSpPr>
         <p:spPr>
           <a:xfrm>
-            <a:off x="32552640" y="25693116"/>
+            <a:off x="32552640" y="25676352"/>
             <a:ext cx="4030675" cy="365760"/>
           </a:xfrm>
           <a:prstGeom prst="rect">
@@ -6340,7 +6340,7 @@
         </p:nvSpPr>
         <p:spPr>
           <a:xfrm>
-            <a:off x="36583315" y="25693116"/>
+            <a:off x="36583315" y="25676352"/>
             <a:ext cx="2227478" cy="365760"/>
           </a:xfrm>
           <a:prstGeom prst="rect">
@@ -6382,7 +6382,7 @@
         </p:nvSpPr>
         <p:spPr>
           <a:xfrm>
-            <a:off x="38810793" y="25693116"/>
+            <a:off x="38810793" y="25676352"/>
             <a:ext cx="2227478" cy="365760"/>
           </a:xfrm>
           <a:prstGeom prst="rect">
@@ -6424,7 +6424,7 @@
         </p:nvSpPr>
         <p:spPr>
           <a:xfrm>
-            <a:off x="41038272" y="25693116"/>
+            <a:off x="41038272" y="25676352"/>
             <a:ext cx="2121408" cy="365760"/>
           </a:xfrm>
           <a:prstGeom prst="rect">
@@ -6466,7 +6466,7 @@
         </p:nvSpPr>
         <p:spPr>
           <a:xfrm>
-            <a:off x="32552640" y="26095452"/>
+            <a:off x="32552640" y="26078688"/>
             <a:ext cx="4030675" cy="365760"/>
           </a:xfrm>
           <a:prstGeom prst="rect">
@@ -6508,7 +6508,7 @@
         </p:nvSpPr>
         <p:spPr>
           <a:xfrm>
-            <a:off x="36583315" y="26095452"/>
+            <a:off x="36583315" y="26078688"/>
             <a:ext cx="2227478" cy="365760"/>
           </a:xfrm>
           <a:prstGeom prst="rect">
@@ -6550,7 +6550,7 @@
         </p:nvSpPr>
         <p:spPr>
           <a:xfrm>
-            <a:off x="38810793" y="26095452"/>
+            <a:off x="38810793" y="26078688"/>
             <a:ext cx="2227478" cy="365760"/>
           </a:xfrm>
           <a:prstGeom prst="rect">
@@ -6592,7 +6592,7 @@
         </p:nvSpPr>
         <p:spPr>
           <a:xfrm>
-            <a:off x="41038272" y="26095452"/>
+            <a:off x="41038272" y="26078688"/>
             <a:ext cx="2121408" cy="365760"/>
           </a:xfrm>
           <a:prstGeom prst="rect">
@@ -6634,7 +6634,7 @@
         </p:nvSpPr>
         <p:spPr>
           <a:xfrm>
-            <a:off x="32552640" y="26497788"/>
+            <a:off x="32552640" y="26481024"/>
             <a:ext cx="4030675" cy="365760"/>
           </a:xfrm>
           <a:prstGeom prst="rect">
@@ -6676,7 +6676,7 @@
         </p:nvSpPr>
         <p:spPr>
           <a:xfrm>
-            <a:off x="36583315" y="26497788"/>
+            <a:off x="36583315" y="26481024"/>
             <a:ext cx="2227478" cy="365760"/>
           </a:xfrm>
           <a:prstGeom prst="rect">
@@ -6718,7 +6718,7 @@
         </p:nvSpPr>
         <p:spPr>
           <a:xfrm>
-            <a:off x="38810793" y="26497788"/>
+            <a:off x="38810793" y="26481024"/>
             <a:ext cx="2227478" cy="365760"/>
           </a:xfrm>
           <a:prstGeom prst="rect">
@@ -6760,7 +6760,7 @@
         </p:nvSpPr>
         <p:spPr>
           <a:xfrm>
-            <a:off x="41038272" y="26497788"/>
+            <a:off x="41038272" y="26481024"/>
             <a:ext cx="2121408" cy="365760"/>
           </a:xfrm>
           <a:prstGeom prst="rect">
@@ -6802,7 +6802,7 @@
         </p:nvSpPr>
         <p:spPr>
           <a:xfrm>
-            <a:off x="32552640" y="26900124"/>
+            <a:off x="32552640" y="26883360"/>
             <a:ext cx="4030675" cy="365760"/>
           </a:xfrm>
           <a:prstGeom prst="rect">
@@ -6844,7 +6844,7 @@
         </p:nvSpPr>
         <p:spPr>
           <a:xfrm>
-            <a:off x="36583315" y="26900124"/>
+            <a:off x="36583315" y="26883360"/>
             <a:ext cx="2227478" cy="365760"/>
           </a:xfrm>
           <a:prstGeom prst="rect">
@@ -6886,7 +6886,7 @@
         </p:nvSpPr>
         <p:spPr>
           <a:xfrm>
-            <a:off x="38810793" y="26900124"/>
+            <a:off x="38810793" y="26883360"/>
             <a:ext cx="2227478" cy="365760"/>
           </a:xfrm>
           <a:prstGeom prst="rect">
@@ -6928,7 +6928,7 @@
         </p:nvSpPr>
         <p:spPr>
           <a:xfrm>
-            <a:off x="41038272" y="26900124"/>
+            <a:off x="41038272" y="26883360"/>
             <a:ext cx="2121408" cy="365760"/>
           </a:xfrm>
           <a:prstGeom prst="rect">
@@ -6970,7 +6970,7 @@
         </p:nvSpPr>
         <p:spPr>
           <a:xfrm>
-            <a:off x="32552640" y="27302460"/>
+            <a:off x="32552640" y="27285696"/>
             <a:ext cx="4030675" cy="365760"/>
           </a:xfrm>
           <a:prstGeom prst="rect">
@@ -7012,7 +7012,7 @@
         </p:nvSpPr>
         <p:spPr>
           <a:xfrm>
-            <a:off x="36583315" y="27302460"/>
+            <a:off x="36583315" y="27285696"/>
             <a:ext cx="2227478" cy="365760"/>
           </a:xfrm>
           <a:prstGeom prst="rect">
@@ -7054,7 +7054,7 @@
         </p:nvSpPr>
         <p:spPr>
           <a:xfrm>
-            <a:off x="38810793" y="27302460"/>
+            <a:off x="38810793" y="27285696"/>
             <a:ext cx="2227478" cy="365760"/>
           </a:xfrm>
           <a:prstGeom prst="rect">
@@ -7096,7 +7096,7 @@
         </p:nvSpPr>
         <p:spPr>
           <a:xfrm>
-            <a:off x="41038272" y="27302460"/>
+            <a:off x="41038272" y="27285696"/>
             <a:ext cx="2121408" cy="365760"/>
           </a:xfrm>
           <a:prstGeom prst="rect">
@@ -7138,7 +7138,7 @@
         </p:nvSpPr>
         <p:spPr>
           <a:xfrm>
-            <a:off x="32552640" y="27732228"/>
+            <a:off x="32552640" y="27715464"/>
             <a:ext cx="10607040" cy="23774"/>
           </a:xfrm>
           <a:prstGeom prst="rect">
@@ -7182,7 +7182,7 @@
         </p:nvSpPr>
         <p:spPr>
           <a:xfrm>
-            <a:off x="731520" y="28290012"/>
+            <a:off x="731520" y="28273248"/>
             <a:ext cx="42428160" cy="20116"/>
           </a:xfrm>
           <a:prstGeom prst="rect">
@@ -7226,7 +7226,7 @@
         </p:nvSpPr>
         <p:spPr>
           <a:xfrm>
-            <a:off x="731520" y="28546044"/>
+            <a:off x="731520" y="28529280"/>
             <a:ext cx="13837920" cy="365760"/>
           </a:xfrm>
           <a:prstGeom prst="rect">
@@ -7268,7 +7268,7 @@
         </p:nvSpPr>
         <p:spPr>
           <a:xfrm>
-            <a:off x="15026640" y="28546044"/>
+            <a:off x="15026640" y="28529280"/>
             <a:ext cx="13837920" cy="365760"/>
           </a:xfrm>
           <a:prstGeom prst="rect">
@@ -7310,7 +7310,7 @@
         </p:nvSpPr>
         <p:spPr>
           <a:xfrm>
-            <a:off x="29321759" y="28546044"/>
+            <a:off x="29321759" y="28529280"/>
             <a:ext cx="13837920" cy="365760"/>
           </a:xfrm>
           <a:prstGeom prst="rect">

</xml_diff>